<commit_message>
Remove AI tool references; add solution zip
</commit_message>
<xml_diff>
--- a/transcript_intelligence.pptx
+++ b/transcript_intelligence.pptx
@@ -2319,7 +2319,7 @@
       </p:sp>
       <p:pic>
         <p:nvPicPr>
-          <p:cNvPr id="5" name="Image 0" descr="/Users/ningliu/Downloads/interview-assignment/outputs/07_action_items.png">    </p:cNvPr>
+          <p:cNvPr id="5" name="Image 0" descr="/Users/ningliu/repo/interview-assignment/outputs/07_action_items.png">    </p:cNvPr>
           <p:cNvPicPr>
             <a:picLocks noChangeAspect="1"/>
           </p:cNvPicPr>
@@ -5808,7 +5808,7 @@
       </p:sp>
       <p:pic>
         <p:nvPicPr>
-          <p:cNvPr id="20" name="Image 0" descr="/Users/ningliu/Downloads/interview-assignment/outputs/01_call_type_distribution.png">    </p:cNvPr>
+          <p:cNvPr id="20" name="Image 0" descr="/Users/ningliu/repo/interview-assignment/outputs/01_call_type_distribution.png">    </p:cNvPr>
           <p:cNvPicPr>
             <a:picLocks noChangeAspect="1"/>
           </p:cNvPicPr>
@@ -6081,7 +6081,7 @@
                   <a:srgbClr val="4A5568"/>
                 </a:solidFill>
               </a:rPr>
-              <a:t>Each transcript's AI-generated summary already contains 4–7 topic tags (e.g., "soc 2 audit", "outage remediation"). These are the raw signal.</a:t>
+              <a:t>Each transcript's pre-processed summary already contains 4–7 topic tags (e.g., "soc 2 audit", "outage remediation"). These are the raw signal.</a:t>
             </a:r>
             <a:endParaRPr lang="en-US" sz="1050" dirty="0"/>
           </a:p>
@@ -6210,7 +6210,7 @@
                   <a:srgbClr val="4A5568"/>
                 </a:solidFill>
               </a:rPr>
-              <a:t>We map those tags to 8 high-level themes using curated keyword lists. 100% of meetings classified — no LLM needed for the first pass.</a:t>
+              <a:t>We map those tags to 8 high-level themes using curated keyword lists. 100% of meetings classified in the first pass.</a:t>
             </a:r>
             <a:endParaRPr lang="en-US" sz="1050" dirty="0"/>
           </a:p>
@@ -6303,7 +6303,7 @@
                   <a:srgbClr val="1B2D5B"/>
                 </a:solidFill>
               </a:rPr>
-              <a:t>3  LLM FALLBACK</a:t>
+              <a:t>3  MODEL FALLBACK</a:t>
             </a:r>
             <a:endParaRPr lang="en-US" sz="1000" dirty="0"/>
           </a:p>
@@ -6339,7 +6339,7 @@
                   <a:srgbClr val="4A5568"/>
                 </a:solidFill>
               </a:rPr>
-              <a:t>Claude API is invoked only for meetings where keyword score = 0 (none here). This makes the pipeline fast and every decision traceable.</a:t>
+              <a:t>A language model API is invoked only for meetings where keyword score = 0 (none here). Keeps the pipeline fast with every decision traceable.</a:t>
             </a:r>
             <a:endParaRPr lang="en-US" sz="1050" dirty="0"/>
           </a:p>
@@ -8727,7 +8727,7 @@
       </p:sp>
       <p:pic>
         <p:nvPicPr>
-          <p:cNvPr id="5" name="Image 0" descr="/Users/ningliu/Downloads/interview-assignment/outputs/03_sentiment_by_call_type.png">    </p:cNvPr>
+          <p:cNvPr id="5" name="Image 0" descr="/Users/ningliu/repo/interview-assignment/outputs/03_sentiment_by_call_type.png">    </p:cNvPr>
           <p:cNvPicPr>
             <a:picLocks noChangeAspect="1"/>
           </p:cNvPicPr>
@@ -9367,7 +9367,7 @@
       </p:sp>
       <p:pic>
         <p:nvPicPr>
-          <p:cNvPr id="5" name="Image 0" descr="/Users/ningliu/Downloads/interview-assignment/outputs/04_sentiment_over_time.png">    </p:cNvPr>
+          <p:cNvPr id="5" name="Image 0" descr="/Users/ningliu/repo/interview-assignment/outputs/04_sentiment_over_time.png">    </p:cNvPr>
           <p:cNvPicPr>
             <a:picLocks noChangeAspect="1"/>
           </p:cNvPicPr>
@@ -9591,7 +9591,7 @@
       </p:sp>
       <p:pic>
         <p:nvPicPr>
-          <p:cNvPr id="5" name="Image 0" descr="/Users/ningliu/Downloads/interview-assignment/outputs/05_churn_risk.png">    </p:cNvPr>
+          <p:cNvPr id="5" name="Image 0" descr="/Users/ningliu/repo/interview-assignment/outputs/05_churn_risk.png">    </p:cNvPr>
           <p:cNvPicPr>
             <a:picLocks noChangeAspect="1"/>
           </p:cNvPicPr>
@@ -10591,7 +10591,7 @@
       </p:sp>
       <p:pic>
         <p:nvPicPr>
-          <p:cNvPr id="5" name="Image 0" descr="/Users/ningliu/Downloads/interview-assignment/outputs/06_speaker_dynamics.png">    </p:cNvPr>
+          <p:cNvPr id="5" name="Image 0" descr="/Users/ningliu/repo/interview-assignment/outputs/06_speaker_dynamics.png">    </p:cNvPr>
           <p:cNvPicPr>
             <a:picLocks noChangeAspect="1"/>
           </p:cNvPicPr>

</xml_diff>